<commit_message>
Adiciona slides de resultado/rastreamento (Aula02, Aula03) e reforça explicações de T(n)/custo marginal com tabelas de instanciação (Aula14)
Co-Authored-By: Claude Sonnet 5 <noreply@anthropic.com>
</commit_message>
<xml_diff>
--- a/Aula04_Problemas_e_Algoritmos/Aula04_Teoria_com_rastreamento.pptx
+++ b/Aula04_Problemas_e_Algoritmos/Aula04_Teoria_com_rastreamento.pptx
@@ -27,6 +27,7 @@
     <p:sldId id="277" r:id="rId28"/>
     <p:sldId id="271" r:id="rId17"/>
     <p:sldId id="272" r:id="rId18"/>
+    <p:sldId id="278" r:id="rId29"/>
   </p:sldIdLst>
   <p:notesMasterIdLst>
     <p:notesMasterId r:id="rId19"/>
@@ -14473,6 +14474,249 @@
 </p:sld>
 </file>
 
+<file path=ppt/slides/slide23.xml><?xml version="1.0" encoding="utf-8"?>
+<p:sld xmlns:a="http://schemas.openxmlformats.org/drawingml/2006/main" xmlns:r="http://schemas.openxmlformats.org/officeDocument/2006/relationships" xmlns:p="http://schemas.openxmlformats.org/presentationml/2006/main">
+  <p:cSld name="Referencias">
+    <p:bg>
+      <p:bgPr>
+        <a:solidFill>
+          <a:srgbClr val="12233B"/>
+        </a:solidFill>
+      </p:bgPr>
+    </p:bg>
+    <p:spTree>
+      <p:nvGrpSpPr>
+        <p:cNvPr id="1" name=""/>
+        <p:cNvGrpSpPr/>
+        <p:nvPr/>
+      </p:nvGrpSpPr>
+      <p:grpSpPr>
+        <a:xfrm>
+          <a:off x="0" y="0"/>
+          <a:ext cx="0" cy="0"/>
+          <a:chOff x="0" y="0"/>
+          <a:chExt cx="0" cy="0"/>
+        </a:xfrm>
+      </p:grpSpPr>
+      <p:sp>
+        <p:nvSpPr>
+          <p:cNvPr id="900" name="Kicker"/>
+          <p:cNvSpPr/>
+          <p:nvPr/>
+        </p:nvSpPr>
+        <p:spPr>
+          <a:xfrm>
+            <a:off x="548626" y="548640"/>
+            <a:ext cx="10484857" cy="411480"/>
+          </a:xfrm>
+          <a:prstGeom prst="rect">
+            <a:avLst/>
+          </a:prstGeom>
+          <a:noFill/>
+          <a:ln/>
+        </p:spPr>
+        <p:txBody>
+          <a:bodyPr wrap="square" lIns="0" tIns="0" rIns="0" bIns="0" rtlCol="0" anchor="ctr"/>
+          <a:lstStyle/>
+          <a:p>
+            <a:pPr indent="0" marL="0">
+              <a:buNone/>
+            </a:pPr>
+            <a:r>
+              <a:rPr lang="pt-BR" sz="1200" b="1" spc="200" kern="0" dirty="0">
+                <a:solidFill>
+                  <a:srgbClr val="E8963C"/>
+                </a:solidFill>
+                <a:latin typeface="Calibri" pitchFamily="34" charset="0"/>
+                <a:ea typeface="Calibri" pitchFamily="34" charset="-122"/>
+                <a:cs typeface="Calibri" pitchFamily="34" charset="-120"/>
+              </a:rPr>
+              <a:t>REFERÊNCIAS</a:t>
+            </a:r>
+            <a:endParaRPr lang="pt-BR" sz="1200" dirty="0"/>
+          </a:p>
+        </p:txBody>
+      </p:sp>
+      <p:sp>
+        <p:nvSpPr>
+          <p:cNvPr id="901" name="Titulo"/>
+          <p:cNvSpPr/>
+          <p:nvPr/>
+        </p:nvSpPr>
+        <p:spPr>
+          <a:xfrm>
+            <a:off x="548626" y="1097280"/>
+            <a:ext cx="10484857" cy="754380"/>
+          </a:xfrm>
+          <a:prstGeom prst="rect">
+            <a:avLst/>
+          </a:prstGeom>
+          <a:noFill/>
+          <a:ln/>
+        </p:spPr>
+        <p:txBody>
+          <a:bodyPr wrap="square" lIns="0" tIns="0" rIns="0" bIns="0" rtlCol="0" anchor="ctr"/>
+          <a:lstStyle/>
+          <a:p>
+            <a:pPr indent="0" marL="0">
+              <a:buNone/>
+            </a:pPr>
+            <a:r>
+              <a:rPr lang="pt-BR" sz="3000" b="1" dirty="0">
+                <a:solidFill>
+                  <a:srgbClr val="FFFFFF"/>
+                </a:solidFill>
+                <a:latin typeface="Cambria" pitchFamily="34" charset="0"/>
+                <a:ea typeface="Cambria" pitchFamily="34" charset="-122"/>
+                <a:cs typeface="Cambria" pitchFamily="34" charset="-120"/>
+              </a:rPr>
+              <a:t>Referências</a:t>
+            </a:r>
+            <a:endParaRPr lang="pt-BR" sz="3000" dirty="0"/>
+          </a:p>
+        </p:txBody>
+      </p:sp>
+      <p:sp>
+        <p:nvSpPr>
+          <p:cNvPr id="902" name="Citacoes"/>
+          <p:cNvSpPr/>
+          <p:nvPr/>
+        </p:nvSpPr>
+        <p:spPr>
+          <a:xfrm>
+            <a:off x="548626" y="2057400"/>
+            <a:ext cx="10484857" cy="4114800"/>
+          </a:xfrm>
+          <a:prstGeom prst="rect">
+            <a:avLst/>
+          </a:prstGeom>
+          <a:noFill/>
+          <a:ln/>
+        </p:spPr>
+        <p:txBody>
+          <a:bodyPr wrap="square" lIns="0" tIns="0" rIns="0" bIns="0" rtlCol="0" anchor="t"/>
+          <a:lstStyle/>
+          <a:p>
+            <a:pPr indent="-228600" marL="228600">
+              <a:lnSpc>
+                <a:spcPct val="125000"/>
+              </a:lnSpc>
+              <a:spcAft>
+                <a:spcPts val="320"/>
+              </a:spcAft>
+              <a:buFont typeface="Arial"/>
+              <a:buChar char="•"/>
+            </a:pPr>
+            <a:r>
+              <a:rPr lang="pt-BR" sz="1400" dirty="0">
+                <a:solidFill>
+                  <a:srgbClr val="E4ECF3"/>
+                </a:solidFill>
+                <a:latin typeface="Calibri" pitchFamily="34" charset="0"/>
+                <a:ea typeface="Calibri" pitchFamily="34" charset="-122"/>
+                <a:cs typeface="Calibri" pitchFamily="34" charset="-120"/>
+              </a:rPr>
+              <a:t>RAABE, André; ZORZO, Avelino F.; BLIKSTEIN, Paulo. Computação na Educação Básica: Fundamentos e Experiências. Porto Alegre: Penso, 2020. Ebook. ISBN 9786581334048.</a:t>
+            </a:r>
+            <a:endParaRPr lang="pt-BR" sz="1400" dirty="0"/>
+          </a:p>
+          <a:p>
+            <a:pPr indent="-228600" marL="228600">
+              <a:lnSpc>
+                <a:spcPct val="125000"/>
+              </a:lnSpc>
+              <a:spcAft>
+                <a:spcPts val="320"/>
+              </a:spcAft>
+              <a:buFont typeface="Arial"/>
+              <a:buChar char="•"/>
+            </a:pPr>
+            <a:r>
+              <a:rPr lang="pt-BR" sz="1400" dirty="0">
+                <a:solidFill>
+                  <a:srgbClr val="E4ECF3"/>
+                </a:solidFill>
+                <a:latin typeface="Calibri" pitchFamily="34" charset="0"/>
+                <a:ea typeface="Calibri" pitchFamily="34" charset="-122"/>
+                <a:cs typeface="Calibri" pitchFamily="34" charset="-120"/>
+              </a:rPr>
+              <a:t>RIBEIRO, João Araújo. Introdução à Programação e aos algoritmos. Rio de Janeiro: LTC, 2019. ISBN 978-85-216-3640-3.</a:t>
+            </a:r>
+            <a:endParaRPr lang="pt-BR" sz="1400" dirty="0"/>
+          </a:p>
+          <a:p>
+            <a:pPr indent="-228600" marL="228600">
+              <a:lnSpc>
+                <a:spcPct val="125000"/>
+              </a:lnSpc>
+              <a:spcAft>
+                <a:spcPts val="320"/>
+              </a:spcAft>
+              <a:buFont typeface="Arial"/>
+              <a:buChar char="•"/>
+            </a:pPr>
+            <a:r>
+              <a:rPr lang="pt-BR" sz="1400" dirty="0">
+                <a:solidFill>
+                  <a:srgbClr val="E4ECF3"/>
+                </a:solidFill>
+                <a:latin typeface="Calibri" pitchFamily="34" charset="0"/>
+                <a:ea typeface="Calibri" pitchFamily="34" charset="-122"/>
+                <a:cs typeface="Calibri" pitchFamily="34" charset="-120"/>
+              </a:rPr>
+              <a:t>Felleisen, M.; Findler, R. B.; Flatt, M.; Krishnamurthi, S. How to Design Programs. The MIT Press, 2001. Disponível em: www.htdp.org</a:t>
+            </a:r>
+            <a:endParaRPr lang="pt-BR" sz="1400" dirty="0"/>
+          </a:p>
+        </p:txBody>
+      </p:sp>
+      <p:sp>
+        <p:nvSpPr>
+          <p:cNvPr id="903" name="Rodape"/>
+          <p:cNvSpPr/>
+          <p:nvPr/>
+        </p:nvSpPr>
+        <p:spPr>
+          <a:xfrm>
+            <a:off x="548626" y="6343650"/>
+            <a:ext cx="10484857" cy="342900"/>
+          </a:xfrm>
+          <a:prstGeom prst="rect">
+            <a:avLst/>
+          </a:prstGeom>
+          <a:noFill/>
+          <a:ln/>
+        </p:spPr>
+        <p:txBody>
+          <a:bodyPr wrap="square" lIns="0" tIns="0" rIns="0" bIns="0" rtlCol="0" anchor="ctr"/>
+          <a:lstStyle/>
+          <a:p>
+            <a:pPr indent="0" marL="0">
+              <a:buNone/>
+            </a:pPr>
+            <a:r>
+              <a:rPr lang="pt-BR" sz="900" dirty="0">
+                <a:solidFill>
+                  <a:srgbClr val="9AA5B1"/>
+                </a:solidFill>
+                <a:latin typeface="Calibri" pitchFamily="34" charset="0"/>
+                <a:ea typeface="Calibri" pitchFamily="34" charset="-122"/>
+                <a:cs typeface="Calibri" pitchFamily="34" charset="-120"/>
+              </a:rPr>
+              <a:t>Aula 4 · Problemas e Algoritmos</a:t>
+            </a:r>
+            <a:endParaRPr lang="pt-BR" sz="900" dirty="0"/>
+          </a:p>
+        </p:txBody>
+      </p:sp>
+    </p:spTree>
+  </p:cSld>
+  <p:clrMapOvr>
+    <a:masterClrMapping/>
+  </p:clrMapOvr>
+</p:sld>
+</file>
+
 <file path=ppt/slides/slide3.xml><?xml version="1.0" encoding="utf-8"?>
 <p:sld xmlns:a="http://schemas.openxmlformats.org/drawingml/2006/main" xmlns:r="http://schemas.openxmlformats.org/officeDocument/2006/relationships" xmlns:p="http://schemas.openxmlformats.org/presentationml/2006/main">
   <p:cSld name="Slide 3">

</xml_diff>